<commit_message>
fix(security): universal API error sanitizer, session DB IP binding, memory leak audit, and 100% test verification
</commit_message>
<xml_diff>
--- a/public/reports/KB_Khata_Testing_Presentation.pptx
+++ b/public/reports/KB_Khata_Testing_Presentation.pptx
@@ -5108,7 +5108,7 @@
                             <a:srgbClr val="64748B"/>
                           </a:solidFill>
                         </a:rPr>
-                        <a:t>2.4 ms</a:t>
+                        <a:t>1.3 ms</a:t>
                       </a:r>
                       <a:endParaRPr lang="en-US" sz="950" dirty="0"/>
                     </a:p>
@@ -5476,7 +5476,7 @@
                             <a:srgbClr val="64748B"/>
                           </a:solidFill>
                         </a:rPr>
-                        <a:t>4.0 ms</a:t>
+                        <a:t>1.3 ms</a:t>
                       </a:r>
                       <a:endParaRPr lang="en-US" sz="950" dirty="0"/>
                     </a:p>
@@ -5844,7 +5844,7 @@
                             <a:srgbClr val="64748B"/>
                           </a:solidFill>
                         </a:rPr>
-                        <a:t>0.6 ms</a:t>
+                        <a:t>0.3 ms</a:t>
                       </a:r>
                       <a:endParaRPr lang="en-US" sz="950" dirty="0"/>
                     </a:p>
@@ -6212,7 +6212,7 @@
                             <a:srgbClr val="64748B"/>
                           </a:solidFill>
                         </a:rPr>
-                        <a:t>0.8 ms</a:t>
+                        <a:t>0.7 ms</a:t>
                       </a:r>
                       <a:endParaRPr lang="en-US" sz="950" dirty="0"/>
                     </a:p>
@@ -6580,7 +6580,7 @@
                             <a:srgbClr val="64748B"/>
                           </a:solidFill>
                         </a:rPr>
-                        <a:t>205.7 ms</a:t>
+                        <a:t>762.9 ms</a:t>
                       </a:r>
                       <a:endParaRPr lang="en-US" sz="950" dirty="0"/>
                     </a:p>
@@ -6948,7 +6948,7 @@
                             <a:srgbClr val="64748B"/>
                           </a:solidFill>
                         </a:rPr>
-                        <a:t>73.7 ms</a:t>
+                        <a:t>123.8 ms</a:t>
                       </a:r>
                       <a:endParaRPr lang="en-US" sz="950" dirty="0"/>
                     </a:p>
@@ -7316,7 +7316,7 @@
                             <a:srgbClr val="64748B"/>
                           </a:solidFill>
                         </a:rPr>
-                        <a:t>476.6 ms</a:t>
+                        <a:t>4638.5 ms</a:t>
                       </a:r>
                       <a:endParaRPr lang="en-US" sz="950" dirty="0"/>
                     </a:p>
@@ -7462,7 +7462,7 @@
                 <a:ea typeface="Arial" pitchFamily="34" charset="-122"/>
                 <a:cs typeface="Arial" pitchFamily="34" charset="-120"/>
               </a:rPr>
-              <a:t>Total Execution Time: 775.44 ms across all 39 automated assertions on production Linux runtime.</a:t>
+              <a:t>Total Execution Time: 5538.17 ms across all 39 automated assertions on production Linux runtime.</a:t>
             </a:r>
             <a:endParaRPr lang="en-US" sz="1000" dirty="0"/>
           </a:p>
@@ -8870,7 +8870,7 @@
                 <a:ea typeface="Arial" pitchFamily="34" charset="-122"/>
                 <a:cs typeface="Arial" pitchFamily="34" charset="-120"/>
               </a:rPr>
-              <a:t>P50: 7.83 ms</a:t>
+              <a:t>P50: 6.85 ms</a:t>
             </a:r>
             <a:endParaRPr lang="en-US" sz="1200" dirty="0"/>
           </a:p>
@@ -8909,7 +8909,7 @@
                 <a:ea typeface="Arial" pitchFamily="34" charset="-122"/>
                 <a:cs typeface="Arial" pitchFamily="34" charset="-120"/>
               </a:rPr>
-              <a:t>P95: 10.43 ms</a:t>
+              <a:t>P95: 14.47 ms</a:t>
             </a:r>
             <a:endParaRPr lang="en-US" sz="1200" dirty="0"/>
           </a:p>

</xml_diff>